<commit_message>
Herschrijf standaarddecks in eigen toon en haal cold e-mail eruit
Co-Authored-By: Claude Fable 5 <noreply@anthropic.com>
Claude-Session: https://claude.ai/code/session_0141FN3f3hHkYQHTyvTJJGrw
</commit_message>
<xml_diff>
--- a/output/LINK. kennismaking.pptx
+++ b/output/LINK. kennismaking.pptx
@@ -2519,7 +2519,7 @@
                 <a:ea typeface="Arial" pitchFamily="34" charset="-122"/>
                 <a:cs typeface="Arial" pitchFamily="34" charset="-120"/>
               </a:rPr>
-              <a:t>Wie we zijn, hoe we werken, wat de standaardpilot inhoudt en hoe we daarna samen opschalen.</a:t>
+              <a:t>Wie we zijn, hoe we werken, wat de pilot van twaalf weken inhoudt en hoe we daarna verder bouwen.</a:t>
             </a:r>
             <a:endParaRPr lang="en-US" sz="1400" dirty="0"/>
           </a:p>
@@ -3768,7 +3768,7 @@
                 <a:ea typeface="Arial" pitchFamily="34" charset="-122"/>
                 <a:cs typeface="Arial" pitchFamily="34" charset="-120"/>
               </a:rPr>
-              <a:t>LINK. is een acquisitiebureau voor B2B-bedrijven. Wij bellen en mailen dagelijks namens onze klanten en leveren gekwalificeerde afspraken op. Geen lijstjes met namen, maar gesprekken in jullie agenda met een beslisser die weet waarom hij aan tafel zit.</a:t>
+              <a:t>LINK. is een acquisitiebureau voor B2B-bedrijven. Wij bellen dagelijks namens onze klanten en leveren gekwalificeerde afspraken op. Geen lijstjes met namen, maar gesprekken in jullie agenda met een beslisser die weet waarom hij aan tafel zit.</a:t>
             </a:r>
             <a:endParaRPr lang="en-US" sz="1350" dirty="0"/>
           </a:p>
@@ -4316,7 +4316,7 @@
                 <a:ea typeface="Arial" pitchFamily="34" charset="-122"/>
                 <a:cs typeface="Arial" pitchFamily="34" charset="-120"/>
               </a:rPr>
-              <a:t>Eén team voor bellen, mailen en </a:t>
+              <a:t>Eén team dat belt, opvolgt en </a:t>
             </a:r>
             <a:pPr algn="l" indent="0" marL="0">
               <a:lnSpc>
@@ -4333,7 +4333,7 @@
                 <a:ea typeface="Georgia" pitchFamily="34" charset="-122"/>
                 <a:cs typeface="Georgia" pitchFamily="34" charset="-120"/>
               </a:rPr>
-              <a:t>opvolgen</a:t>
+              <a:t>afspraken levert</a:t>
             </a:r>
             <a:pPr algn="l" indent="0" marL="0">
               <a:lnSpc>
@@ -4612,7 +4612,7 @@
                 <a:ea typeface="Arial" pitchFamily="34" charset="-122"/>
                 <a:cs typeface="Arial" pitchFamily="34" charset="-120"/>
               </a:rPr>
-              <a:t>Cold e-mail</a:t>
+              <a:t>Data en doelgroep</a:t>
             </a:r>
             <a:endParaRPr lang="en-US" sz="1350" dirty="0"/>
           </a:p>
@@ -4654,7 +4654,7 @@
                 <a:ea typeface="Arial" pitchFamily="34" charset="-122"/>
                 <a:cs typeface="Arial" pitchFamily="34" charset="-120"/>
               </a:rPr>
-              <a:t>Korte, persoonlijke mails als opening of als opvolging van een gesprek. Geen massamails, één relevant bericht per bedrijf, in jullie tone of voice.</a:t>
+              <a:t>Wij bouwen de bellijst op basis van jullie ideale klant: branche, grootte, regio en functie. Bestaande relaties en uitsluitingen halen we er vooraf uit.</a:t>
             </a:r>
             <a:endParaRPr lang="en-US" sz="950" dirty="0"/>
           </a:p>
@@ -4764,7 +4764,7 @@
                 <a:ea typeface="Arial" pitchFamily="34" charset="-122"/>
                 <a:cs typeface="Arial" pitchFamily="34" charset="-120"/>
               </a:rPr>
-              <a:t>Data en doelgroep</a:t>
+              <a:t>Opvolging</a:t>
             </a:r>
             <a:endParaRPr lang="en-US" sz="1350" dirty="0"/>
           </a:p>
@@ -4806,7 +4806,7 @@
                 <a:ea typeface="Arial" pitchFamily="34" charset="-122"/>
                 <a:cs typeface="Arial" pitchFamily="34" charset="-120"/>
               </a:rPr>
-              <a:t>Wij bouwen de bellijst op basis van jullie ideale klantprofiel: branche, grootte, regio en functie. Bestaande relaties en uitsluitingen halen we er vooraf uit.</a:t>
+              <a:t>Terugbelafspraken komen echt terug in de bellijst en warme leads dragen we direct aan jullie over, met de reden en de context erbij.</a:t>
             </a:r>
             <a:endParaRPr lang="en-US" sz="950" dirty="0"/>
           </a:p>
@@ -5403,7 +5403,7 @@
                 <a:ea typeface="Arial" pitchFamily="34" charset="-122"/>
                 <a:cs typeface="Arial" pitchFamily="34" charset="-120"/>
               </a:rPr>
-              <a:t>Samen scherp: doelgroep, beslisser, propositie, bezwaren en wat een goede afspraak voor jullie is. Wij schrijven het belscript en de mails, jullie keuren goed.</a:t>
+              <a:t>Samen scherp: doelgroep, beslisser, propositie, bezwaren en wat een goede afspraak voor jullie is. Wij schrijven het belscript, jullie keuren goed.</a:t>
             </a:r>
             <a:endParaRPr lang="en-US" sz="900" dirty="0"/>
           </a:p>
@@ -7389,7 +7389,7 @@
                 <a:ea typeface="Arial" pitchFamily="34" charset="-122"/>
                 <a:cs typeface="Arial" pitchFamily="34" charset="-120"/>
               </a:rPr>
-              <a:t>Propositie en strategie</a:t>
+              <a:t>Kick-off en belscript</a:t>
             </a:r>
             <a:endParaRPr lang="en-US" sz="1150" dirty="0"/>
           </a:p>
@@ -7431,7 +7431,7 @@
                 <a:ea typeface="Arial" pitchFamily="34" charset="-122"/>
                 <a:cs typeface="Arial" pitchFamily="34" charset="-120"/>
               </a:rPr>
-              <a:t>Samen scherp in de kick-off: doelgroep, beslisser, boodschap en bezwaren. Wij schrijven het belscript en de mails, jullie keuren goed.</a:t>
+              <a:t>Samen scherp wat we gaan vertellen en bij wie. Wij schrijven het belscript, jullie keuren het goed.</a:t>
             </a:r>
             <a:endParaRPr lang="en-US" sz="875" dirty="0"/>
           </a:p>
@@ -7603,7 +7603,7 @@
                 <a:ea typeface="Arial" pitchFamily="34" charset="-122"/>
                 <a:cs typeface="Arial" pitchFamily="34" charset="-120"/>
               </a:rPr>
-              <a:t>Wij bouwen de bellijst op jullie ideale klantprofiel: branche, grootte, regio en functie. Bestaande relaties en uitsluitingen halen we er vooraf uit.</a:t>
+              <a:t>Wij bouwen de bellijst op jullie ideale klant: branche, grootte, regio en functie. Bestaande relaties en uitsluitingen gaan er vooraf uit.</a:t>
             </a:r>
             <a:endParaRPr lang="en-US" sz="875" dirty="0"/>
           </a:p>
@@ -7733,7 +7733,7 @@
                 <a:ea typeface="Arial" pitchFamily="34" charset="-122"/>
                 <a:cs typeface="Arial" pitchFamily="34" charset="-120"/>
               </a:rPr>
-              <a:t>Twaalf weken uitvoering</a:t>
+              <a:t>Twaalf weken bellen</a:t>
             </a:r>
             <a:endParaRPr lang="en-US" sz="1150" dirty="0"/>
           </a:p>
@@ -7775,7 +7775,7 @@
                 <a:ea typeface="Arial" pitchFamily="34" charset="-122"/>
                 <a:cs typeface="Arial" pitchFamily="34" charset="-120"/>
               </a:rPr>
-              <a:t>Dagelijks bellen met een regionaal nummer op jullie naam, korte persoonlijke mails als opening en opvolging. Rapportage elke week, evaluatie om de week.</a:t>
+              <a:t>Elke werkdag bellen met een regionaal nummer op jullie naam. Elke week een rapportage en om de week zitten we samen om bij te sturen.</a:t>
             </a:r>
             <a:endParaRPr lang="en-US" sz="875" dirty="0"/>
           </a:p>
@@ -7947,7 +7947,7 @@
                 <a:ea typeface="Arial" pitchFamily="34" charset="-122"/>
                 <a:cs typeface="Arial" pitchFamily="34" charset="-120"/>
               </a:rPr>
-              <a:t>Fit: het bedrijf past bij de criteria uit de kick-off. Interesse: er is een concrete aanleiding of vraag. Beslisser: de afspraak staat met wie over de aankoop gaat.</a:t>
+              <a:t>Elke afspraak voldoet aan drie eisen: het bedrijf past, de interesse is echt en de juiste persoon zit aan tafel.</a:t>
             </a:r>
             <a:endParaRPr lang="en-US" sz="875" dirty="0"/>
           </a:p>
@@ -8174,7 +8174,7 @@
                 <a:ea typeface="Arial" pitchFamily="34" charset="-122"/>
                 <a:cs typeface="Arial" pitchFamily="34" charset="-120"/>
               </a:rPr>
-              <a:t>Propositie, belscript en mails</a:t>
+              <a:t>Kick-off en belscript</a:t>
             </a:r>
             <a:endParaRPr lang="en-US" sz="900" dirty="0"/>
           </a:p>
@@ -8237,7 +8237,7 @@
                 <a:ea typeface="Arial" pitchFamily="34" charset="-122"/>
                 <a:cs typeface="Arial" pitchFamily="34" charset="-120"/>
               </a:rPr>
-              <a:t>Bellijst op jullie ideale klantprofiel</a:t>
+              <a:t>Bellijst op jullie ideale klant</a:t>
             </a:r>
             <a:endParaRPr lang="en-US" sz="900" dirty="0"/>
           </a:p>
@@ -8363,7 +8363,7 @@
                 <a:ea typeface="Arial" pitchFamily="34" charset="-122"/>
                 <a:cs typeface="Arial" pitchFamily="34" charset="-120"/>
               </a:rPr>
-              <a:t>Twaalf weken dagelijks bellen en mailen</a:t>
+              <a:t>Twaalf weken elke werkdag bellen</a:t>
             </a:r>
             <a:endParaRPr lang="en-US" sz="900" dirty="0"/>
           </a:p>
@@ -8733,7 +8733,7 @@
                 <a:ea typeface="Arial" pitchFamily="34" charset="-122"/>
                 <a:cs typeface="Arial" pitchFamily="34" charset="-120"/>
               </a:rPr>
-              <a:t>Van tien afspraken naar een </a:t>
+              <a:t>Daarna weet je precies wat </a:t>
             </a:r>
             <a:pPr algn="l" indent="0" marL="0">
               <a:lnSpc>
@@ -8750,7 +8750,7 @@
                 <a:ea typeface="Georgia" pitchFamily="34" charset="-122"/>
                 <a:cs typeface="Georgia" pitchFamily="34" charset="-120"/>
               </a:rPr>
-              <a:t>groeiplan</a:t>
+              <a:t>werkt</a:t>
             </a:r>
             <a:pPr algn="l" indent="0" marL="0">
               <a:lnSpc>
@@ -8934,7 +8934,7 @@
                 <a:ea typeface="Arial" pitchFamily="34" charset="-122"/>
                 <a:cs typeface="Arial" pitchFamily="34" charset="-120"/>
               </a:rPr>
-              <a:t>Na twaalf weken weten we wat tien gekwalificeerde afspraken opleveren: hoe de gesprekken gingen, hoeveel offertes eruit kwamen en hoeveel klanten jullie eruit halen.</a:t>
+              <a:t>Na de pilot weet je wat tien afspraken opleveren: hoe de gesprekken gingen, wat eruit kwam en hoeveel klanten je eruit haalt.</a:t>
             </a:r>
             <a:endParaRPr lang="en-US" sz="1050" dirty="0"/>
           </a:p>
@@ -9101,7 +9101,7 @@
                 <a:ea typeface="Arial" pitchFamily="34" charset="-122"/>
                 <a:cs typeface="Arial" pitchFamily="34" charset="-120"/>
               </a:rPr>
-              <a:t>Daarmee staat jullie eigen rekensom: zoveel afspraken zijn er nodig voor één nieuwe klant. Geen aannames, maar cijfers uit jullie eigen markt.</a:t>
+              <a:t>Dan weet je ook hoeveel afspraken je nodig hebt voor één nieuwe klant. Niet geschat, maar gewoon geteld.</a:t>
             </a:r>
             <a:endParaRPr lang="en-US" sz="1050" dirty="0"/>
           </a:p>
@@ -9243,7 +9243,7 @@
                 <a:ea typeface="Arial" pitchFamily="34" charset="-122"/>
                 <a:cs typeface="Arial" pitchFamily="34" charset="-120"/>
               </a:rPr>
-              <a:t>Jullie kiezen hoeveel nieuwe klanten je per vier weken wilt. Wij rekenen dat terug naar afspraken en gesprekken en richten de samenwerking daarop in.</a:t>
+              <a:t>Jij zegt hoeveel nieuwe klanten je per vier weken wilt. Wij rekenen terug hoeveel afspraken daarvoor nodig zijn en richten de samenwerking daarop in.</a:t>
             </a:r>
             <a:endParaRPr lang="en-US" sz="1050" dirty="0"/>
           </a:p>
@@ -9302,7 +9302,7 @@
                 <a:ea typeface="Arial" pitchFamily="34" charset="-122"/>
                 <a:cs typeface="Arial" pitchFamily="34" charset="-120"/>
               </a:rPr>
-              <a:t>Zo groeit het vervolg niet op gevoel, maar op jullie eigen cijfers.</a:t>
+              <a:t>Zo beslis je over het vervolg met je eigen cijfers in de hand.</a:t>
             </a:r>
             <a:endParaRPr lang="en-US" sz="1200" dirty="0"/>
           </a:p>
@@ -9985,7 +9985,7 @@
                 <a:ea typeface="Arial" pitchFamily="34" charset="-122"/>
                 <a:cs typeface="Arial" pitchFamily="34" charset="-120"/>
               </a:rPr>
-              <a:t>Goedkeuring script en mails</a:t>
+              <a:t>Goedkeuring belscript</a:t>
             </a:r>
             <a:endParaRPr lang="en-US" sz="1450" dirty="0"/>
           </a:p>

</xml_diff>

<commit_message>
Zet partner-framing in de kennismakingsdeck in plaats van bureau
Co-Authored-By: Claude Fable 5 <noreply@anthropic.com>
Claude-Session: https://claude.ai/code/session_0141FN3f3hHkYQHTyvTJJGrw
</commit_message>
<xml_diff>
--- a/output/LINK. kennismaking.pptx
+++ b/output/LINK. kennismaking.pptx
@@ -3768,7 +3768,7 @@
                 <a:ea typeface="Arial" pitchFamily="34" charset="-122"/>
                 <a:cs typeface="Arial" pitchFamily="34" charset="-120"/>
               </a:rPr>
-              <a:t>LINK. is een acquisitiebureau voor B2B-bedrijven. Wij bellen dagelijks namens onze klanten en leveren gekwalificeerde afspraken op. Geen lijstjes met namen, maar gesprekken in jullie agenda met een beslisser die weet waarom hij aan tafel zit.</a:t>
+              <a:t>LINK. is de vaste acquisitiepartner van B2B-bedrijven. Wij bellen dagelijks namens onze klanten en leveren gekwalificeerde afspraken op. Geen lijstjes met namen, maar gesprekken in jullie agenda met een beslisser die weet waarom hij aan tafel zit.</a:t>
             </a:r>
             <a:endParaRPr lang="en-US" sz="1350" dirty="0"/>
           </a:p>
@@ -3788,7 +3788,7 @@
                 <a:ea typeface="Arial" pitchFamily="34" charset="-122"/>
                 <a:cs typeface="Arial" pitchFamily="34" charset="-120"/>
               </a:rPr>
-              <a:t>We werken voor bedrijven met een sterke B2B-propositie in uiteenlopende branches: van koffie voor kantoren en videoproductie tot CO2-certificaten, cybersecurity en interieurbeplanting.</a:t>
+              <a:t>We werken voor bedrijven met een sterke B2B-propositie in uiteenlopende branches: van koffie voor kantoren en videoproductie tot CO2-certificaten, cybersecurity en interieurbeplanting. Geen bureau op afstand, maar een partner die elke week met je schakelt.</a:t>
             </a:r>
             <a:endParaRPr lang="en-US" sz="1350" dirty="0"/>
           </a:p>

</xml_diff>